<commit_message>
feat: presentations updated as per prof. vm instructions
</commit_message>
<xml_diff>
--- a/courses/development-and-application-of-computer-hardware-accelerators/homework/02_control_flow_manycore_execution_model_sillicon_implementation_technology/presentation/02_control_flow_manycore_execution_model_sillicon_implementation_technology.pptx
+++ b/courses/development-and-application-of-computer-hardware-accelerators/homework/02_control_flow_manycore_execution_model_sillicon_implementation_technology/presentation/02_control_flow_manycore_execution_model_sillicon_implementation_technology.pptx
@@ -126,6 +126,7 @@
 <file path=ppt/revisionInfo.xml><?xml version="1.0" encoding="utf-8"?>
 <p1510:revInfo xmlns:a="http://schemas.openxmlformats.org/drawingml/2006/main" xmlns:r="http://schemas.openxmlformats.org/officeDocument/2006/relationships" xmlns:p1510="http://schemas.microsoft.com/office/powerpoint/2015/10/main">
   <p1510:revLst>
+    <p1510:client id="{0D0474F9-9DF6-D400-4707-6F4BEFDC7C64}" v="15" dt="2026-05-08T14:49:28.039"/>
     <p1510:client id="{B0975C63-F1F2-02A2-5C17-9ADAB4249246}" v="961" dt="2026-05-08T10:50:53.957"/>
     <p1510:client id="{F817D6D9-3DDC-DE22-470A-520EB04E7455}" v="942" dt="2026-05-08T07:33:29.653"/>
   </p1510:revLst>
@@ -701,6 +702,7 @@
   <p:clrMapOvr>
     <a:masterClrMapping/>
   </p:clrMapOvr>
+  <p:hf hdr="0" ftr="0" dt="0"/>
 </p:sldLayout>
 </file>
 
@@ -901,6 +903,7 @@
   <p:clrMapOvr>
     <a:masterClrMapping/>
   </p:clrMapOvr>
+  <p:hf hdr="0" ftr="0" dt="0"/>
 </p:sldLayout>
 </file>
 
@@ -1111,6 +1114,7 @@
   <p:clrMapOvr>
     <a:masterClrMapping/>
   </p:clrMapOvr>
+  <p:hf hdr="0" ftr="0" dt="0"/>
 </p:sldLayout>
 </file>
 
@@ -1311,6 +1315,7 @@
   <p:clrMapOvr>
     <a:masterClrMapping/>
   </p:clrMapOvr>
+  <p:hf hdr="0" ftr="0" dt="0"/>
 </p:sldLayout>
 </file>
 
@@ -1587,6 +1592,7 @@
   <p:clrMapOvr>
     <a:masterClrMapping/>
   </p:clrMapOvr>
+  <p:hf hdr="0" ftr="0" dt="0"/>
 </p:sldLayout>
 </file>
 
@@ -1855,6 +1861,7 @@
   <p:clrMapOvr>
     <a:masterClrMapping/>
   </p:clrMapOvr>
+  <p:hf hdr="0" ftr="0" dt="0"/>
 </p:sldLayout>
 </file>
 
@@ -2270,6 +2277,7 @@
   <p:clrMapOvr>
     <a:masterClrMapping/>
   </p:clrMapOvr>
+  <p:hf hdr="0" ftr="0" dt="0"/>
 </p:sldLayout>
 </file>
 
@@ -2412,6 +2420,7 @@
   <p:clrMapOvr>
     <a:masterClrMapping/>
   </p:clrMapOvr>
+  <p:hf hdr="0" ftr="0" dt="0"/>
 </p:sldLayout>
 </file>
 
@@ -2525,6 +2534,7 @@
   <p:clrMapOvr>
     <a:masterClrMapping/>
   </p:clrMapOvr>
+  <p:hf hdr="0" ftr="0" dt="0"/>
 </p:sldLayout>
 </file>
 
@@ -2838,6 +2848,7 @@
   <p:clrMapOvr>
     <a:masterClrMapping/>
   </p:clrMapOvr>
+  <p:hf hdr="0" ftr="0" dt="0"/>
 </p:sldLayout>
 </file>
 
@@ -3127,6 +3138,7 @@
   <p:clrMapOvr>
     <a:masterClrMapping/>
   </p:clrMapOvr>
+  <p:hf hdr="0" ftr="0" dt="0"/>
 </p:sldLayout>
 </file>
 
@@ -3417,6 +3429,7 @@
     <p:sldLayoutId id="2147483658" r:id="rId10"/>
     <p:sldLayoutId id="2147483659" r:id="rId11"/>
   </p:sldLayoutIdLst>
+  <p:hf hdr="0" ftr="0" dt="0"/>
   <p:txStyles>
     <p:titleStyle>
       <a:lvl1pPr algn="l" defTabSz="914400" rtl="0" eaLnBrk="1" latinLnBrk="0" hangingPunct="1">
@@ -4050,6 +4063,39 @@
           </a:p>
         </p:txBody>
       </p:sp>
+      <p:sp>
+        <p:nvSpPr>
+          <p:cNvPr id="2" name="Slide Number Placeholder 1">
+            <a:extLst>
+              <a:ext uri="{FF2B5EF4-FFF2-40B4-BE49-F238E27FC236}">
+                <a16:creationId xmlns:a16="http://schemas.microsoft.com/office/drawing/2014/main" id="{E1AB7275-2162-0441-2D23-887194E30F77}"/>
+              </a:ext>
+            </a:extLst>
+          </p:cNvPr>
+          <p:cNvSpPr>
+            <a:spLocks noGrp="1"/>
+          </p:cNvSpPr>
+          <p:nvPr>
+            <p:ph type="sldNum" sz="quarter" idx="12"/>
+          </p:nvPr>
+        </p:nvSpPr>
+        <p:spPr/>
+        <p:txBody>
+          <a:bodyPr/>
+          <a:lstStyle/>
+          <a:p>
+            <a:fld id="{2FD4CC91-F09A-4F5A-BB07-0020C8970CD5}" type="slidenum">
+              <a:rPr lang="sr-Latn-RS" dirty="0" smtClean="0"/>
+              <a:t>1</a:t>
+            </a:fld>
+            <a:r>
+              <a:rPr lang="sr-Latn-RS"/>
+              <a:t>/9</a:t>
+            </a:r>
+            <a:endParaRPr lang="en-US"/>
+          </a:p>
+        </p:txBody>
+      </p:sp>
     </p:spTree>
     <p:extLst>
       <p:ext uri="{BB962C8B-B14F-4D97-AF65-F5344CB8AC3E}">
@@ -4291,6 +4337,39 @@
           </a:p>
         </p:txBody>
       </p:sp>
+      <p:sp>
+        <p:nvSpPr>
+          <p:cNvPr id="4" name="Slide Number Placeholder 3">
+            <a:extLst>
+              <a:ext uri="{FF2B5EF4-FFF2-40B4-BE49-F238E27FC236}">
+                <a16:creationId xmlns:a16="http://schemas.microsoft.com/office/drawing/2014/main" id="{F8B4C4B6-31C5-9AC3-DADE-1E91B6BBE75B}"/>
+              </a:ext>
+            </a:extLst>
+          </p:cNvPr>
+          <p:cNvSpPr>
+            <a:spLocks noGrp="1"/>
+          </p:cNvSpPr>
+          <p:nvPr>
+            <p:ph type="sldNum" sz="quarter" idx="12"/>
+          </p:nvPr>
+        </p:nvSpPr>
+        <p:spPr/>
+        <p:txBody>
+          <a:bodyPr/>
+          <a:lstStyle/>
+          <a:p>
+            <a:fld id="{2FD4CC91-F09A-4F5A-BB07-0020C8970CD5}" type="slidenum">
+              <a:rPr lang="sr-Latn-RS" dirty="0" smtClean="0"/>
+              <a:t>2</a:t>
+            </a:fld>
+            <a:r>
+              <a:rPr lang="sr-Latn-RS"/>
+              <a:t>/9</a:t>
+            </a:r>
+            <a:endParaRPr lang="en-US"/>
+          </a:p>
+        </p:txBody>
+      </p:sp>
     </p:spTree>
     <p:extLst>
       <p:ext uri="{BB962C8B-B14F-4D97-AF65-F5344CB8AC3E}">
@@ -4595,6 +4674,39 @@
           </a:p>
         </p:txBody>
       </p:sp>
+      <p:sp>
+        <p:nvSpPr>
+          <p:cNvPr id="4" name="Slide Number Placeholder 3">
+            <a:extLst>
+              <a:ext uri="{FF2B5EF4-FFF2-40B4-BE49-F238E27FC236}">
+                <a16:creationId xmlns:a16="http://schemas.microsoft.com/office/drawing/2014/main" id="{D625ABF3-0FE2-B384-5B15-27981221DBB9}"/>
+              </a:ext>
+            </a:extLst>
+          </p:cNvPr>
+          <p:cNvSpPr>
+            <a:spLocks noGrp="1"/>
+          </p:cNvSpPr>
+          <p:nvPr>
+            <p:ph type="sldNum" sz="quarter" idx="12"/>
+          </p:nvPr>
+        </p:nvSpPr>
+        <p:spPr/>
+        <p:txBody>
+          <a:bodyPr/>
+          <a:lstStyle/>
+          <a:p>
+            <a:fld id="{2FD4CC91-F09A-4F5A-BB07-0020C8970CD5}" type="slidenum">
+              <a:rPr lang="sr-Latn-RS" dirty="0" smtClean="0"/>
+              <a:t>3</a:t>
+            </a:fld>
+            <a:r>
+              <a:rPr lang="sr-Latn-RS"/>
+              <a:t>/9</a:t>
+            </a:r>
+            <a:endParaRPr lang="en-US"/>
+          </a:p>
+        </p:txBody>
+      </p:sp>
     </p:spTree>
     <p:extLst>
       <p:ext uri="{BB962C8B-B14F-4D97-AF65-F5344CB8AC3E}">
@@ -5519,6 +5631,39 @@
           </a:p>
         </p:txBody>
       </p:sp>
+      <p:sp>
+        <p:nvSpPr>
+          <p:cNvPr id="4" name="Slide Number Placeholder 3">
+            <a:extLst>
+              <a:ext uri="{FF2B5EF4-FFF2-40B4-BE49-F238E27FC236}">
+                <a16:creationId xmlns:a16="http://schemas.microsoft.com/office/drawing/2014/main" id="{5E625248-1DE5-90FF-08EB-F0BA4ECAB015}"/>
+              </a:ext>
+            </a:extLst>
+          </p:cNvPr>
+          <p:cNvSpPr>
+            <a:spLocks noGrp="1"/>
+          </p:cNvSpPr>
+          <p:nvPr>
+            <p:ph type="sldNum" sz="quarter" idx="12"/>
+          </p:nvPr>
+        </p:nvSpPr>
+        <p:spPr/>
+        <p:txBody>
+          <a:bodyPr/>
+          <a:lstStyle/>
+          <a:p>
+            <a:fld id="{2FD4CC91-F09A-4F5A-BB07-0020C8970CD5}" type="slidenum">
+              <a:rPr lang="sr-Latn-RS" dirty="0" smtClean="0"/>
+              <a:t>4</a:t>
+            </a:fld>
+            <a:r>
+              <a:rPr lang="sr-Latn-RS"/>
+              <a:t>/9</a:t>
+            </a:r>
+            <a:endParaRPr lang="en-US"/>
+          </a:p>
+        </p:txBody>
+      </p:sp>
     </p:spTree>
     <p:extLst>
       <p:ext uri="{BB962C8B-B14F-4D97-AF65-F5344CB8AC3E}">
@@ -5622,6 +5767,39 @@
           </a:prstGeom>
         </p:spPr>
       </p:pic>
+      <p:sp>
+        <p:nvSpPr>
+          <p:cNvPr id="3" name="Slide Number Placeholder 2">
+            <a:extLst>
+              <a:ext uri="{FF2B5EF4-FFF2-40B4-BE49-F238E27FC236}">
+                <a16:creationId xmlns:a16="http://schemas.microsoft.com/office/drawing/2014/main" id="{30CE460A-D451-63D4-AC2E-6AD6E9E384ED}"/>
+              </a:ext>
+            </a:extLst>
+          </p:cNvPr>
+          <p:cNvSpPr>
+            <a:spLocks noGrp="1"/>
+          </p:cNvSpPr>
+          <p:nvPr>
+            <p:ph type="sldNum" sz="quarter" idx="12"/>
+          </p:nvPr>
+        </p:nvSpPr>
+        <p:spPr/>
+        <p:txBody>
+          <a:bodyPr/>
+          <a:lstStyle/>
+          <a:p>
+            <a:fld id="{2FD4CC91-F09A-4F5A-BB07-0020C8970CD5}" type="slidenum">
+              <a:rPr lang="sr-Latn-RS" dirty="0" smtClean="0"/>
+              <a:t>5</a:t>
+            </a:fld>
+            <a:r>
+              <a:rPr lang="sr-Latn-RS"/>
+              <a:t>/9</a:t>
+            </a:r>
+            <a:endParaRPr lang="en-US"/>
+          </a:p>
+        </p:txBody>
+      </p:sp>
     </p:spTree>
     <p:extLst>
       <p:ext uri="{BB962C8B-B14F-4D97-AF65-F5344CB8AC3E}">
@@ -5698,6 +5876,39 @@
           </a:prstGeom>
         </p:spPr>
       </p:pic>
+      <p:sp>
+        <p:nvSpPr>
+          <p:cNvPr id="2" name="Slide Number Placeholder 1">
+            <a:extLst>
+              <a:ext uri="{FF2B5EF4-FFF2-40B4-BE49-F238E27FC236}">
+                <a16:creationId xmlns:a16="http://schemas.microsoft.com/office/drawing/2014/main" id="{89FFA03A-3024-3AEC-6BD6-801F1497D456}"/>
+              </a:ext>
+            </a:extLst>
+          </p:cNvPr>
+          <p:cNvSpPr>
+            <a:spLocks noGrp="1"/>
+          </p:cNvSpPr>
+          <p:nvPr>
+            <p:ph type="sldNum" sz="quarter" idx="12"/>
+          </p:nvPr>
+        </p:nvSpPr>
+        <p:spPr/>
+        <p:txBody>
+          <a:bodyPr/>
+          <a:lstStyle/>
+          <a:p>
+            <a:fld id="{2FD4CC91-F09A-4F5A-BB07-0020C8970CD5}" type="slidenum">
+              <a:rPr lang="sr-Latn-RS" dirty="0" smtClean="0"/>
+              <a:t>6</a:t>
+            </a:fld>
+            <a:r>
+              <a:rPr lang="sr-Latn-RS"/>
+              <a:t>/9</a:t>
+            </a:r>
+            <a:endParaRPr lang="en-US"/>
+          </a:p>
+        </p:txBody>
+      </p:sp>
     </p:spTree>
     <p:extLst>
       <p:ext uri="{BB962C8B-B14F-4D97-AF65-F5344CB8AC3E}">
@@ -5774,6 +5985,39 @@
           </a:prstGeom>
         </p:spPr>
       </p:pic>
+      <p:sp>
+        <p:nvSpPr>
+          <p:cNvPr id="2" name="Slide Number Placeholder 1">
+            <a:extLst>
+              <a:ext uri="{FF2B5EF4-FFF2-40B4-BE49-F238E27FC236}">
+                <a16:creationId xmlns:a16="http://schemas.microsoft.com/office/drawing/2014/main" id="{D0F50C85-8251-D551-BB42-7231D3BD7AD8}"/>
+              </a:ext>
+            </a:extLst>
+          </p:cNvPr>
+          <p:cNvSpPr>
+            <a:spLocks noGrp="1"/>
+          </p:cNvSpPr>
+          <p:nvPr>
+            <p:ph type="sldNum" sz="quarter" idx="12"/>
+          </p:nvPr>
+        </p:nvSpPr>
+        <p:spPr/>
+        <p:txBody>
+          <a:bodyPr/>
+          <a:lstStyle/>
+          <a:p>
+            <a:fld id="{2FD4CC91-F09A-4F5A-BB07-0020C8970CD5}" type="slidenum">
+              <a:rPr lang="sr-Latn-RS" dirty="0" smtClean="0"/>
+              <a:t>7</a:t>
+            </a:fld>
+            <a:r>
+              <a:rPr lang="sr-Latn-RS"/>
+              <a:t>/9</a:t>
+            </a:r>
+            <a:endParaRPr lang="en-US"/>
+          </a:p>
+        </p:txBody>
+      </p:sp>
     </p:spTree>
     <p:extLst>
       <p:ext uri="{BB962C8B-B14F-4D97-AF65-F5344CB8AC3E}">
@@ -5850,6 +6094,39 @@
           </a:prstGeom>
         </p:spPr>
       </p:pic>
+      <p:sp>
+        <p:nvSpPr>
+          <p:cNvPr id="2" name="Slide Number Placeholder 1">
+            <a:extLst>
+              <a:ext uri="{FF2B5EF4-FFF2-40B4-BE49-F238E27FC236}">
+                <a16:creationId xmlns:a16="http://schemas.microsoft.com/office/drawing/2014/main" id="{D9901E63-A82E-3C94-CAC9-DBC2D8F1837C}"/>
+              </a:ext>
+            </a:extLst>
+          </p:cNvPr>
+          <p:cNvSpPr>
+            <a:spLocks noGrp="1"/>
+          </p:cNvSpPr>
+          <p:nvPr>
+            <p:ph type="sldNum" sz="quarter" idx="12"/>
+          </p:nvPr>
+        </p:nvSpPr>
+        <p:spPr/>
+        <p:txBody>
+          <a:bodyPr/>
+          <a:lstStyle/>
+          <a:p>
+            <a:fld id="{2FD4CC91-F09A-4F5A-BB07-0020C8970CD5}" type="slidenum">
+              <a:rPr lang="sr-Latn-RS" dirty="0" smtClean="0"/>
+              <a:t>8</a:t>
+            </a:fld>
+            <a:r>
+              <a:rPr lang="sr-Latn-RS"/>
+              <a:t>/9</a:t>
+            </a:r>
+            <a:endParaRPr lang="en-US"/>
+          </a:p>
+        </p:txBody>
+      </p:sp>
     </p:spTree>
     <p:extLst>
       <p:ext uri="{BB962C8B-B14F-4D97-AF65-F5344CB8AC3E}">
@@ -5926,6 +6203,39 @@
           </a:prstGeom>
         </p:spPr>
       </p:pic>
+      <p:sp>
+        <p:nvSpPr>
+          <p:cNvPr id="2" name="Slide Number Placeholder 1">
+            <a:extLst>
+              <a:ext uri="{FF2B5EF4-FFF2-40B4-BE49-F238E27FC236}">
+                <a16:creationId xmlns:a16="http://schemas.microsoft.com/office/drawing/2014/main" id="{DC861C39-80D6-C7E5-D04B-AD19137F26B2}"/>
+              </a:ext>
+            </a:extLst>
+          </p:cNvPr>
+          <p:cNvSpPr>
+            <a:spLocks noGrp="1"/>
+          </p:cNvSpPr>
+          <p:nvPr>
+            <p:ph type="sldNum" sz="quarter" idx="12"/>
+          </p:nvPr>
+        </p:nvSpPr>
+        <p:spPr/>
+        <p:txBody>
+          <a:bodyPr/>
+          <a:lstStyle/>
+          <a:p>
+            <a:fld id="{2FD4CC91-F09A-4F5A-BB07-0020C8970CD5}" type="slidenum">
+              <a:rPr lang="sr-Latn-RS" dirty="0" smtClean="0"/>
+              <a:t>9</a:t>
+            </a:fld>
+            <a:r>
+              <a:rPr lang="sr-Latn-RS"/>
+              <a:t>/9</a:t>
+            </a:r>
+            <a:endParaRPr lang="en-US"/>
+          </a:p>
+        </p:txBody>
+      </p:sp>
     </p:spTree>
     <p:extLst>
       <p:ext uri="{BB962C8B-B14F-4D97-AF65-F5344CB8AC3E}">

</xml_diff>